<commit_message>
Update theme to darker blue
</commit_message>
<xml_diff>
--- a/paper/final_report/TM/figures/1.pptx
+++ b/paper/final_report/TM/figures/1.pptx
@@ -3399,12 +3399,12 @@
         </p:nvSpPr>
         <p:spPr>
           <a:xfrm>
-            <a:off x="464626" y="136569"/>
-            <a:ext cx="4625789" cy="3779902"/>
+            <a:off x="464626" y="135467"/>
+            <a:ext cx="4829863" cy="4109156"/>
           </a:xfrm>
           <a:prstGeom prst="halfFrame">
             <a:avLst>
-              <a:gd name="adj1" fmla="val 33333"/>
+              <a:gd name="adj1" fmla="val 27564"/>
               <a:gd name="adj2" fmla="val 31938"/>
             </a:avLst>
           </a:prstGeom>
@@ -3461,7 +3461,7 @@
         </p:nvSpPr>
         <p:spPr>
           <a:xfrm>
-            <a:off x="464626" y="2877011"/>
+            <a:off x="464626" y="2775410"/>
             <a:ext cx="6083209" cy="461665"/>
           </a:xfrm>
           <a:prstGeom prst="rect">
@@ -3502,7 +3502,7 @@
         </p:nvSpPr>
         <p:spPr>
           <a:xfrm>
-            <a:off x="353558" y="5165271"/>
+            <a:off x="376136" y="5165271"/>
             <a:ext cx="2818219" cy="923330"/>
           </a:xfrm>
           <a:prstGeom prst="rect">
@@ -3537,8 +3537,8 @@
         </p:nvSpPr>
         <p:spPr>
           <a:xfrm>
-            <a:off x="1495058" y="1866482"/>
-            <a:ext cx="5052777" cy="830997"/>
+            <a:off x="1495058" y="1527812"/>
+            <a:ext cx="5052777" cy="923330"/>
           </a:xfrm>
           <a:prstGeom prst="rect">
             <a:avLst/>
@@ -3553,9 +3553,10 @@
           <a:p>
             <a:pPr algn="r"/>
             <a:r>
-              <a:rPr lang="en-US" altLang="zh-CN" sz="4800" b="1" dirty="0"/>
-              <a:t>Court Sweeper</a:t>
-            </a:r>
+              <a:rPr lang="en-US" altLang="zh-CN" sz="5400" b="1" dirty="0" err="1"/>
+              <a:t>CourtSweeper</a:t>
+            </a:r>
+            <a:endParaRPr lang="en-US" altLang="zh-CN" sz="5400" b="1" dirty="0"/>
           </a:p>
         </p:txBody>
       </p:sp>

</xml_diff>